<commit_message>
Clarify YieldWindow evidence boundary
</commit_message>
<xml_diff>
--- a/docs/submission/pitch-deck.pptx
+++ b/docs/submission/pitch-deck.pptx
@@ -2,19 +2,19 @@
 <file path=ppt/presentation.xml><?xml version="1.0" encoding="utf-8"?>
 <p:presentation xmlns:p="http://schemas.openxmlformats.org/presentationml/2006/main">
   <p:sldMasterIdLst>
-    <p:sldMasterId xmlns:r="http://schemas.openxmlformats.org/officeDocument/2006/relationships" id="2147483648" r:id="Rd28b9ecd74c44d28"/>
+    <p:sldMasterId xmlns:r="http://schemas.openxmlformats.org/officeDocument/2006/relationships" id="2147483648" r:id="R30258c0f37854269"/>
   </p:sldMasterIdLst>
   <p:notesMasterIdLst>
-    <p:notesMasterId xmlns:r="http://schemas.openxmlformats.org/officeDocument/2006/relationships" r:id="R1789c1927dae4fb2"/>
+    <p:notesMasterId xmlns:r="http://schemas.openxmlformats.org/officeDocument/2006/relationships" r:id="R853f55d3b28d4c47"/>
   </p:notesMasterIdLst>
   <p:sldIdLst>
-    <p:sldId xmlns:r="http://schemas.openxmlformats.org/officeDocument/2006/relationships" id="256" r:id="Ra6e708188f634fbd"/>
-    <p:sldId xmlns:r="http://schemas.openxmlformats.org/officeDocument/2006/relationships" id="257" r:id="R3bc192296f02493e"/>
-    <p:sldId xmlns:r="http://schemas.openxmlformats.org/officeDocument/2006/relationships" id="258" r:id="Rceca61c024f44ffa"/>
-    <p:sldId xmlns:r="http://schemas.openxmlformats.org/officeDocument/2006/relationships" id="259" r:id="R787918cd570f4420"/>
-    <p:sldId xmlns:r="http://schemas.openxmlformats.org/officeDocument/2006/relationships" id="260" r:id="R1d70bed3f673408f"/>
-    <p:sldId xmlns:r="http://schemas.openxmlformats.org/officeDocument/2006/relationships" id="261" r:id="R1fa5abecb6c840a5"/>
-    <p:sldId xmlns:r="http://schemas.openxmlformats.org/officeDocument/2006/relationships" id="262" r:id="R36e2383260984813"/>
+    <p:sldId xmlns:r="http://schemas.openxmlformats.org/officeDocument/2006/relationships" id="256" r:id="R0a98542d82bc49d4"/>
+    <p:sldId xmlns:r="http://schemas.openxmlformats.org/officeDocument/2006/relationships" id="257" r:id="Rc899bd35a95a4f6c"/>
+    <p:sldId xmlns:r="http://schemas.openxmlformats.org/officeDocument/2006/relationships" id="258" r:id="R0a852c5d155b4866"/>
+    <p:sldId xmlns:r="http://schemas.openxmlformats.org/officeDocument/2006/relationships" id="259" r:id="Rf35100de00044c24"/>
+    <p:sldId xmlns:r="http://schemas.openxmlformats.org/officeDocument/2006/relationships" id="260" r:id="Ra7e9adcca2024dc1"/>
+    <p:sldId xmlns:r="http://schemas.openxmlformats.org/officeDocument/2006/relationships" id="261" r:id="Rce0f541d9e844364"/>
+    <p:sldId xmlns:r="http://schemas.openxmlformats.org/officeDocument/2006/relationships" id="262" r:id="Rd7d99a1fc48b4b59"/>
   </p:sldIdLst>
   <p:sldSz cx="12192000" cy="6858000"/>
   <p:notesSz cx="6858000" cy="9144000"/>
@@ -1153,7 +1153,7 @@
           </a:p>
           <a:p xmlns:a="http://schemas.openxmlformats.org/drawingml/2006/main">
             <a:r>
-              <a:t>Boundary: Today: real market data + plan receipt + jTRX write-path canary. The USDT/USDD plan remains simulated.</a:t>
+              <a:t>Boundary: The Nile receipt uses fallback demo parameters. A separate live 1-TRX jTRX mint/redeem canary succeeded. USDT/USDD execution remains simulated.</a:t>
             </a:r>
           </a:p>
           <a:p xmlns:a="http://schemas.openxmlformats.org/drawingml/2006/main">
@@ -1226,7 +1226,7 @@
   </p:cSld>
   <p:clrMap bg1="lt1" tx1="dk1" bg2="lt2" tx2="dk2" accent1="accent1" accent2="accent2" accent3="accent3" accent4="accent4" accent5="accent5" accent6="accent6" hlink="hlink" folHlink="folHlink"/>
   <p:sldLayoutIdLst>
-    <p:sldLayoutId xmlns:r="http://schemas.openxmlformats.org/officeDocument/2006/relationships" id="2147483649" r:id="R9f8e8760f24e4462"/>
+    <p:sldLayoutId xmlns:r="http://schemas.openxmlformats.org/officeDocument/2006/relationships" id="2147483649" r:id="R420cb2fae99741db"/>
   </p:sldLayoutIdLst>
   <p:txStyles>
     <p:titleStyle>
@@ -2233,14 +2233,14 @@
       </p:sp>
       <p:pic>
         <p:nvPicPr>
-          <p:cNvPr id="21" name=""/>
+          <p:cNvPr id="23" name=""/>
           <p:cNvPicPr>
             <a:picLocks xmlns:a="http://schemas.openxmlformats.org/drawingml/2006/main" noChangeAspect="1"/>
           </p:cNvPicPr>
           <p:nvPr/>
         </p:nvPicPr>
         <p:blipFill>
-          <a:blip xmlns:r="http://schemas.openxmlformats.org/officeDocument/2006/relationships" xmlns:a="http://schemas.openxmlformats.org/drawingml/2006/main" r:embed="R48b51c21a88a474c"/>
+          <a:blip xmlns:r="http://schemas.openxmlformats.org/officeDocument/2006/relationships" xmlns:a="http://schemas.openxmlformats.org/drawingml/2006/main" r:embed="R8af9b6ae138c427a"/>
           <a:srcRect xmlns:a="http://schemas.openxmlformats.org/drawingml/2006/main" l="10000" t="8000" r="2000" b="3000"/>
           <a:stretch xmlns:a="http://schemas.openxmlformats.org/drawingml/2006/main"/>
         </p:blipFill>
@@ -2807,14 +2807,14 @@
       </p:sp>
       <p:pic>
         <p:nvPicPr>
-          <p:cNvPr id="33" name=""/>
+          <p:cNvPr id="35" name=""/>
           <p:cNvPicPr>
             <a:picLocks xmlns:a="http://schemas.openxmlformats.org/drawingml/2006/main" noChangeAspect="1"/>
           </p:cNvPicPr>
           <p:nvPr/>
         </p:nvPicPr>
         <p:blipFill>
-          <a:blip xmlns:r="http://schemas.openxmlformats.org/officeDocument/2006/relationships" xmlns:a="http://schemas.openxmlformats.org/drawingml/2006/main" r:embed="Rfd160c944fad4d0b"/>
+          <a:blip xmlns:r="http://schemas.openxmlformats.org/officeDocument/2006/relationships" xmlns:a="http://schemas.openxmlformats.org/drawingml/2006/main" r:embed="Ra112616490474ab9"/>
           <a:srcRect xmlns:a="http://schemas.openxmlformats.org/drawingml/2006/main" l="0" t="2000" r="0" b="73000"/>
           <a:stretch xmlns:a="http://schemas.openxmlformats.org/drawingml/2006/main"/>
         </p:blipFill>
@@ -5497,14 +5497,14 @@
       </p:sp>
       <p:pic>
         <p:nvPicPr>
-          <p:cNvPr id="37" name=""/>
+          <p:cNvPr id="39" name=""/>
           <p:cNvPicPr>
             <a:picLocks xmlns:a="http://schemas.openxmlformats.org/drawingml/2006/main" noChangeAspect="1"/>
           </p:cNvPicPr>
           <p:nvPr/>
         </p:nvPicPr>
         <p:blipFill>
-          <a:blip xmlns:r="http://schemas.openxmlformats.org/officeDocument/2006/relationships" xmlns:a="http://schemas.openxmlformats.org/drawingml/2006/main" r:embed="Rdba2e35281504365"/>
+          <a:blip xmlns:r="http://schemas.openxmlformats.org/officeDocument/2006/relationships" xmlns:a="http://schemas.openxmlformats.org/drawingml/2006/main" r:embed="R018576de01c24634"/>
           <a:srcRect xmlns:a="http://schemas.openxmlformats.org/drawingml/2006/main" l="4000" t="30000" r="4000" b="38000"/>
           <a:stretch xmlns:a="http://schemas.openxmlformats.org/drawingml/2006/main"/>
         </p:blipFill>
@@ -7957,14 +7957,14 @@
       </p:sp>
       <p:pic>
         <p:nvPicPr>
-          <p:cNvPr id="61" name=""/>
+          <p:cNvPr id="63" name=""/>
           <p:cNvPicPr>
             <a:picLocks xmlns:a="http://schemas.openxmlformats.org/drawingml/2006/main" noChangeAspect="1"/>
           </p:cNvPicPr>
           <p:nvPr/>
         </p:nvPicPr>
         <p:blipFill>
-          <a:blip xmlns:r="http://schemas.openxmlformats.org/officeDocument/2006/relationships" xmlns:a="http://schemas.openxmlformats.org/drawingml/2006/main" r:embed="R436bf9c5ab564eb3"/>
+          <a:blip xmlns:r="http://schemas.openxmlformats.org/officeDocument/2006/relationships" xmlns:a="http://schemas.openxmlformats.org/drawingml/2006/main" r:embed="Rb8597a12cc2847f4"/>
           <a:srcRect xmlns:a="http://schemas.openxmlformats.org/drawingml/2006/main" l="0" t="55000" r="0" b="14000"/>
           <a:stretch xmlns:a="http://schemas.openxmlformats.org/drawingml/2006/main"/>
         </p:blipFill>
@@ -10840,7 +10840,7 @@
                 <a:ea typeface="Helvetica Neue"/>
                 <a:cs typeface="Helvetica Neue"/>
               </a:rPr>
-              <a:t>Official market snapshots</a:t>
+              <a:t>Labeled fallback demo parameters</a:t>
             </a:r>
           </a:p>
         </p:txBody>
@@ -11084,7 +11084,7 @@
                 <a:ea typeface="Helvetica Neue"/>
                 <a:cs typeface="Helvetica Neue"/>
               </a:rPr>
-              <a:t>Live jTRX mint + redeem canary</a:t>
+              <a:t>Live 1-TRX jTRX mint + redeem</a:t>
             </a:r>
           </a:p>
         </p:txBody>
@@ -12284,7 +12284,7 @@
                 <a:ea typeface="Helvetica Neue"/>
                 <a:cs typeface="Helvetica Neue"/>
               </a:rPr>
-              <a:t>Today: real market data + plan receipt + jTRX write-path canary. The USDT/USDD plan remains simulated.</a:t>
+              <a:t>The Nile receipt uses fallback demo parameters. A separate live 1-TRX jTRX mint/redeem canary succeeded. USDT/USDD execution remains simulated.</a:t>
             </a:r>
           </a:p>
         </p:txBody>

</xml_diff>